<commit_message>
Final Presentation Slide upload
</commit_message>
<xml_diff>
--- a/Capsule-Counterfeit-Detection-Using-Deep-Learning.pptx
+++ b/Capsule-Counterfeit-Detection-Using-Deep-Learning.pptx
@@ -25,7 +25,7 @@
   <p:notesSz cx="8229600" cy="14630400"/>
   <p:embeddedFontLst>
     <p:embeddedFont>
-      <p:font typeface="Barlow Bold" panose="00000800000000000000" pitchFamily="2" charset="0"/>
+      <p:font typeface="Barlow Bold" panose="020B0604020202020204" charset="0"/>
       <p:bold r:id="rId15"/>
     </p:embeddedFont>
     <p:embeddedFont>
@@ -8720,7 +8720,7 @@
                 <a:ea typeface="Montserrat" pitchFamily="34" charset="-122"/>
                 <a:cs typeface="Montserrat" pitchFamily="34" charset="-120"/>
               </a:rPr>
-              <a:t>Accuracy: 0.9965</a:t>
+              <a:t>Accuracy: 0.8965</a:t>
             </a:r>
             <a:r>
               <a:rPr lang="en-US" sz="1700" dirty="0">
@@ -8774,7 +8774,7 @@
                 <a:ea typeface="Montserrat" pitchFamily="34" charset="-122"/>
                 <a:cs typeface="Montserrat" pitchFamily="34" charset="-120"/>
               </a:rPr>
-              <a:t>Precision: 0.9962</a:t>
+              <a:t>Precision: 0.8662</a:t>
             </a:r>
             <a:r>
               <a:rPr lang="en-US" sz="1700" dirty="0">
@@ -8828,7 +8828,7 @@
                 <a:ea typeface="Montserrat" pitchFamily="34" charset="-122"/>
                 <a:cs typeface="Montserrat" pitchFamily="34" charset="-120"/>
               </a:rPr>
-              <a:t>Recall: 0.9968</a:t>
+              <a:t>Recall: 0.9314</a:t>
             </a:r>
             <a:r>
               <a:rPr lang="en-US" sz="1700" dirty="0">
@@ -8882,7 +8882,7 @@
                 <a:ea typeface="Montserrat" pitchFamily="34" charset="-122"/>
                 <a:cs typeface="Montserrat" pitchFamily="34" charset="-120"/>
               </a:rPr>
-              <a:t>F1 Score: 0.9965</a:t>
+              <a:t>F1 Score: 0.8962</a:t>
             </a:r>
             <a:r>
               <a:rPr lang="en-US" sz="1700" dirty="0">

</xml_diff>